<commit_message>
Complete SkillCraft marketplace workflow and reviews
</commit_message>
<xml_diff>
--- a/docs/SkillCraft_DBTHON_2026_Panel.pptx
+++ b/docs/SkillCraft_DBTHON_2026_Panel.pptx
@@ -6,20 +6,21 @@
   </p:sldMasterIdLst>
   <p:sldIdLst>
     <p:sldId id="256" r:id="rId7"/>
-    <p:sldId id="257" r:id="rId9"/>
-    <p:sldId id="258" r:id="rId10"/>
-    <p:sldId id="259" r:id="rId11"/>
-    <p:sldId id="260" r:id="rId12"/>
-    <p:sldId id="261" r:id="rId13"/>
-    <p:sldId id="262" r:id="rId14"/>
-    <p:sldId id="263" r:id="rId15"/>
-    <p:sldId id="264" r:id="rId16"/>
-    <p:sldId id="265" r:id="rId17"/>
-    <p:sldId id="266" r:id="rId18"/>
-    <p:sldId id="267" r:id="rId19"/>
-    <p:sldId id="268" r:id="rId20"/>
-    <p:sldId id="269" r:id="rId21"/>
-    <p:sldId id="270" r:id="rId22"/>
+    <p:sldId id="257" r:id="rId8"/>
+    <p:sldId id="258" r:id="rId9"/>
+    <p:sldId id="259" r:id="rId10"/>
+    <p:sldId id="260" r:id="rId11"/>
+    <p:sldId id="261" r:id="rId12"/>
+    <p:sldId id="262" r:id="rId13"/>
+    <p:sldId id="263" r:id="rId14"/>
+    <p:sldId id="264" r:id="rId15"/>
+    <p:sldId id="265" r:id="rId16"/>
+    <p:sldId id="266" r:id="rId17"/>
+    <p:sldId id="267" r:id="rId18"/>
+    <p:sldId id="268" r:id="rId19"/>
+    <p:sldId id="269" r:id="rId20"/>
+    <p:sldId id="270" r:id="rId21"/>
+    <p:sldId id="271" r:id="rId22"/>
   </p:sldIdLst>
   <p:sldSz cx="12191695" cy="6858000" type="screen4x3"/>
   <p:notesSz cx="6858000" cy="9144000"/>
@@ -516,7 +517,7 @@
           <a:lstStyle/>
           <a:p>
             <a:r>
-              <a:t>Open with one sentence: SkillCraft is a local-work marketplace whose main strength is the database record behind each job. Introduce the team.</a:t>
+              <a:t>Good morning. We are presenting SkillCraft, a working prototype for finding and managing small local jobs. An employer posts a job, artisans offer a price, and one accepted offer becomes a contract. Our central idea is that each decision should leave a connected database record, so the original brief, competing offers, agreement, payment acknowledgments, and review can be traced later. Vedika, Bhavyaveer, and Anuj built this prototype for DBTHON 2026 under the guidance of Siva Sankari. I will show the user journey first, then the database rules that make the record dependable, and finally the evidence and remaining limits.</a:t>
             </a:r>
           </a:p>
         </p:txBody>
@@ -586,7 +587,7 @@
           <a:lstStyle/>
           <a:p>
             <a:r>
-              <a:t>Use the search screen to show a match label. Say the ranking is transparent, not AI. Explain row-level security in ordinary words: the database itself filters rows based on the signed-in user's identity.</a:t>
+              <a:t>SkillCraft also uses the database for discovery. Search can filter jobs or artisans by skill and match location or keywords using indexed queries. A simple fit score gives two points for the same skill and one for the same city, for a total from zero to three. Anyone can inspect why a result ranked where it did; this is a rule, not an AI prediction. For private data, the API uses a restricted database role and passes the signed-in identity to row-level policies. Public reputation comes through limited views, while private bids, contracts, events, and account fields have narrower access.</a:t>
             </a:r>
           </a:p>
         </p:txBody>
@@ -656,7 +657,7 @@
           <a:lstStyle/>
           <a:p>
             <a:r>
-              <a:t>Do not present test counts as a speed-up. These tests show behavior and integrity. Native PostgreSQL query-plan and ranking-quality comparisons are still planned.</a:t>
+              <a:t>We separate three kinds of evidence. Schema and API tests exercise the job-to-review journey, ownership rules, contract events, and payment transition against fresh PGlite databases. A separate Jest suite has twenty CRUD cases and four integrity or concurrent-acceptance cases, also on PGlite. The two browser checks cover interface behavior in visual demo mode, so they do not prove a live database connection. Together, these checks support functional behavior in a controlled local setup. They do not establish a search speed-up, ranking quality, native PostgreSQL concurrency, or social impact. Those claims need a baseline, repeatable dataset, measurements, and a native server run.</a:t>
             </a:r>
           </a:p>
         </p:txBody>
@@ -726,7 +727,7 @@
           <a:lstStyle/>
           <a:p>
             <a:r>
-              <a:t>Tie every rubric criterion to one visible artifact. State that these are maximum marks allocated by the challenge PDF, not an estimated grade.</a:t>
+              <a:t>The first four rubric lines total eighteen available marks; these are criteria, not points already awarded to us. For the problem and domain, we show the broken chat-based workflow and the two user roles. For database design, we show the seven-table ER model, keys, constraints, and normalization rationale. For DBMS depth, we can point to the acceptance transaction, trigger, views, indexes, and row policies in the SQL. For innovation, the clearest evidence is the two-party payment sequence and append-only contract history. If the panel asks for proof, we can move from each claim to a table, SQL rule, or live action.</a:t>
             </a:r>
           </a:p>
         </p:txBody>
@@ -796,7 +797,7 @@
           <a:lstStyle/>
           <a:p>
             <a:r>
-              <a:t>The last two criteria are easy to overstate. Describe SDG alignment as an intention; describe TRL as a working prototype rather than a deployed or field-tested system.</a:t>
+              <a:t>The remaining four criteria total twelve available marks. On novelty, our comparison is with a simple employer-only paid flag and a plain review average; it is a design comparison, not a measured market advantage. On SDG alignment, we can explain the intended route to fairer access and portable history, while acknowledging that outcomes are unmeasured. On validation, we have passing functional tests but still need a native PostgreSQL benchmark and labeled matching examples. On readiness, we can run a two-account local demonstration, but there has been no field pilot. Matching each claim to its present evidence is how we intend to answer the panel fairly.</a:t>
             </a:r>
           </a:p>
         </p:txBody>
@@ -866,7 +867,7 @@
           <a:lstStyle/>
           <a:p>
             <a:r>
-              <a:t>Prepare a fresh job before the demo and use its distinctive description to search. Avoid posting a new bid on a previously bid job. Both accounts use password123 in the local seeded preview.</a:t>
+              <a:t>Now I will use the connected preview with two seeded accounts. As Ramesh, I post a new job with a distinctive title and budget. I switch to Lakshmi, search for that job, and submit a bid. Back as Ramesh, I accept her offer; we can see the job close and one contract appear. I record payment sent, then switch to Lakshmi to confirm receipt. The contract becomes paid, so Ramesh can leave a review. Finally, I show the event sequence and updated trust score. This is the actual API and database path, not the browser-only visual demo. I will pause at each transition to show the record it produced.</a:t>
             </a:r>
           </a:p>
         </p:txBody>
@@ -936,7 +937,77 @@
           <a:lstStyle/>
           <a:p>
             <a:r>
-              <a:t>Close by restating the database contribution. Invite questions. If asked about payment, distinguish acknowledgment from real bank verification. If asked about performance, explain the planned benchmark rather than inventing a result.</a:t>
+              <a:t>Three questions deserve direct answers. First, can two artisans both win one job? The transaction, job-row lock, trigger, and unique contract rule work together to prevent that outcome; our local test checks it, and a native server run remains. Second, does paid mean money was verified? No. It means the employer reported sending payment and the artisan reported receiving it. Third, where is the measured improvement? We have not claimed one. We still need a defined baseline, enough data, repeated native PostgreSQL queries, and labeled examples for ranking quality. These limits help keep the prototype's claims precise.</a:t>
+            </a:r>
+          </a:p>
+        </p:txBody>
+      </p:sp>
+      <p:sp>
+        <p:nvSpPr>
+          <p:cNvPr id="4" name="Slide Number Placeholder 3"/>
+          <p:cNvSpPr>
+            <a:spLocks noGrp="1"/>
+          </p:cNvSpPr>
+          <p:nvPr>
+            <p:ph type="sldNum" idx="5" sz="quarter"/>
+          </p:nvPr>
+        </p:nvSpPr>
+        <p:spPr/>
+      </p:sp>
+    </p:spTree>
+  </p:cSld>
+  <p:clrMapOvr>
+    <a:masterClrMapping/>
+  </p:clrMapOvr>
+</p:notes>
+</file>
+
+<file path=ppt/notesSlides/notesSlide16.xml><?xml version="1.0" encoding="utf-8"?>
+<p:notes xmlns:a="http://schemas.openxmlformats.org/drawingml/2006/main" xmlns:p="http://schemas.openxmlformats.org/presentationml/2006/main" xmlns:r="http://schemas.openxmlformats.org/officeDocument/2006/relationships">
+  <p:cSld>
+    <p:spTree>
+      <p:nvGrpSpPr>
+        <p:cNvPr id="1" name=""/>
+        <p:cNvGrpSpPr/>
+        <p:nvPr/>
+      </p:nvGrpSpPr>
+      <p:grpSpPr>
+        <a:xfrm>
+          <a:off x="0" y="0"/>
+          <a:ext cx="0" cy="0"/>
+          <a:chOff x="0" y="0"/>
+          <a:chExt cx="0" cy="0"/>
+        </a:xfrm>
+      </p:grpSpPr>
+      <p:sp>
+        <p:nvSpPr>
+          <p:cNvPr id="2" name="Slide Image Placeholder 1"/>
+          <p:cNvSpPr>
+            <a:spLocks noGrp="1"/>
+          </p:cNvSpPr>
+          <p:nvPr>
+            <p:ph type="sldImg" idx="2"/>
+          </p:nvPr>
+        </p:nvSpPr>
+        <p:spPr/>
+      </p:sp>
+      <p:sp>
+        <p:nvSpPr>
+          <p:cNvPr id="3" name="Notes Placeholder 2"/>
+          <p:cNvSpPr>
+            <a:spLocks noGrp="1"/>
+          </p:cNvSpPr>
+          <p:nvPr>
+            <p:ph type="body" idx="3" sz="quarter"/>
+          </p:nvPr>
+        </p:nvSpPr>
+        <p:spPr/>
+        <p:txBody>
+          <a:bodyPr/>
+          <a:lstStyle/>
+          <a:p>
+            <a:r>
+              <a:t>SkillCraft's contribution is a connected, enforceable record of a local job: the brief, every bid, one chosen worker, a contract, two payment acknowledgments, and a review. The working prototype demonstrates this through two roles and seven related tables. The database carries the important guarantees, including one contract per job, ownership rules, append-only events, and automatic trust-score updates. The next work is to measure search performance and match quality on a defined baseline, repeat security and concurrency checks on native PostgreSQL, and learn from a real pilot. SkillCraft records user claims about payment; it does not transfer or independently verify money. Thank you; we welcome questions.</a:t>
             </a:r>
           </a:p>
         </p:txBody>
@@ -1006,7 +1077,7 @@
           <a:lstStyle/>
           <a:p>
             <a:r>
-              <a:t>Explain the old approach first: informal messages do not create a dependable sequence. Then state the target users and SDG 8 connection. Do not claim proven earnings gains.</a:t>
+              <a:t>Imagine arranging a repair job through calls and chat. A week later, the employer and worker may struggle to establish which price was accepted, whether another bidder was declined, or whether payment was acknowledged. SkillCraft gives local artisans a place to discover work and gives employers a structured way to compare offers. It stores the whole sequence as linked records instead of relying on scattered messages. This relates to Sustainable Development Goal 8 because access to work and a portable work history could matter economically. That is a design goal: we have not yet measured changes in earnings or access.</a:t>
             </a:r>
           </a:p>
         </p:txBody>
@@ -1076,7 +1147,7 @@
           <a:lstStyle/>
           <a:p>
             <a:r>
-              <a:t>Use Ramesh and Lakshmi as the concrete example. Emphasize that accepting a bid creates exactly one contract and that paid status for a new contract needs both sides.</a:t>
+              <a:t>Here is one complete example using our seeded accounts, Ramesh the employer and Lakshmi the artisan. Ramesh posts a job with its skill, location, and budget. Lakshmi finds it and submits a bid. Ramesh accepts one offer; the job closes, competing pending bids are rejected, and one contract is created. For a new contract, Ramesh then records that payment was sent, and Lakshmi separately confirms receipt. Only after both actions is the contract marked paid and eligible for a review. When Ramesh reviews the work, the database updates Lakshmi's trust score. Each step remains connected to the original job.</a:t>
             </a:r>
           </a:p>
         </p:txBody>
@@ -1146,7 +1217,7 @@
           <a:lstStyle/>
           <a:p>
             <a:r>
-              <a:t>Show the actual role navigation in the live prototype. Ramesh cannot use artisan bid actions; Lakshmi cannot post jobs or inspect someone else's bids.</a:t>
+              <a:t>The two accounts share the same underlying job, but they have different actions. Ramesh can post a brief, inspect offers on his own jobs, choose a worker, record payment sent, and review an eligible contract. Lakshmi can search open work, bid, follow the outcome, and confirm receipt on a contract awarded to her. This separation is more than a different menu. The API checks each user's role and ownership, and a restricted database role applies row-level rules to private bids, contracts, and events. For example, another employer cannot inspect or accept bids on Ramesh's job.</a:t>
             </a:r>
           </a:p>
         </p:txBody>
@@ -1216,7 +1287,7 @@
           <a:lstStyle/>
           <a:p>
             <a:r>
-              <a:t>React is the visible website. Express is the server API. PostgreSQL is the relational database that joins records and enforces integrity. PGlite is the local preview database, not a separate product design.</a:t>
+              <a:t>This diagram separates what the visitor sees from where the workflow rules live. React and Vite provide the pages and forms. The Express API authenticates requests and checks who is allowed to perform an action. The relational database stores linked records and enforces key rules with constraints, transactions, functions, triggers, and policies. Our local connected preview runs the PostgreSQL-compatible schema in PGlite, which makes the demo self-contained. The Docker setup specifies PostgreSQL 15, but we do not treat a local PGlite result as a native PostgreSQL performance result. The next slide shows the tables behind this architecture.</a:t>
             </a:r>
           </a:p>
         </p:txBody>
@@ -1286,7 +1357,7 @@
           <a:lstStyle/>
           <a:p>
             <a:r>
-              <a:t>Point to USERS, then GIG_POSTINGS, GIG_APPLICATIONS, COMPLETION_CONTRACTS, and finally RATINGS_REVIEWS plus CONTRACT_EVENTS. The accepted-bid trigger creates the contract; there is no direct bid-to-contract foreign key.</a:t>
+              <a:t>Read this diagram from the shared USERS table. An artisan profile belongs to a user, while each GIG_POSTINGS row identifies its employer. A job can receive many GIG_APPLICATIONS, but an artisan can bid only once on that job. Accepting an application causes a database trigger to create one COMPLETION_CONTRACTS row for the job and select that artisan. A contract can have one RATINGS_REVIEWS row and many CONTRACT_EVENTS rows. The events preserve the sequence of contract actions. Primary and foreign keys keep the relationships valid; the unique contract-per-job rule prevents a second agreement for the same job. The full model contains seven tables.</a:t>
             </a:r>
           </a:p>
         </p:txBody>
@@ -1356,7 +1427,7 @@
           <a:lstStyle/>
           <a:p>
             <a:r>
-              <a:t>One of the strongest demonstrations is two attempts to accept different bids on the same job. Exactly one succeeds. Do not attribute the result to a single mechanism; the lock, transaction, trigger and unique constraint work together.</a:t>
+              <a:t>The hardest moment is when two offers for one job are accepted close together. Our API processes acceptance in a serializable transaction and locks the job row before checking that it is still open. The database trigger closes the job, rejects other pending bids, and creates the contract. A unique constraint on the contract's job ID adds another barrier to a second winner. Amount and status checks reject invalid records, while payment functions enforce the two acknowledgment steps. Our local tests confirm the one-winner behavior in PGlite. Native PostgreSQL server concurrency still needs a separate run, so we do not claim measured throughput here.</a:t>
             </a:r>
           </a:p>
         </p:txBody>
@@ -1426,7 +1497,7 @@
           <a:lstStyle/>
           <a:p>
             <a:r>
-              <a:t>This is the main novelty story. Acknowledgments are assertions by users, not bank verification. Explain why old paid rows are labelled legacy: the migration refuses to invent an artisan confirmation.</a:t>
+              <a:t>A single paid flag loses an important distinction: who said that payment happened? For new SkillCraft contracts, the employer first records payment sent. The selected artisan then confirms receipt. The contract changes to paid only after both timestamps exist, and database triggers append events identifying the action and actor. Those event rows cannot be edited or deleted through the supported database path. This is an auditable sequence of user claims, not proof of a bank transfer. Earlier sample contracts that were already paid remain visibly marked as legacy; the migration does not invent an artisan confirmation that never happened.</a:t>
             </a:r>
           </a:p>
         </p:txBody>
@@ -1496,7 +1567,7 @@
           <a:lstStyle/>
           <a:p>
             <a:r>
-              <a:t>Explain the prior without jargon: one perfect review should not immediately make a new artisan look perfect. The stored score is recalculated by a database trigger after a real eligible review. This is a design choice, not a validated fairness guarantee.</a:t>
+              <a:t>Reviews are connected to contracts, and a new contract must be paid before it can be reviewed. We then recalculate the artisan's stored score from eligible reviews. The formula starts with the equivalent of three virtual reviews at three and a half stars, so one new five-star review produces about 3.88, not a perfect five. This reduces the swing from a single early review. A database trigger runs the calculation after a review is inserted, keeping the displayed score in step with the record. The prior is a deliberate design choice; we have not tested whether it improves fairness or predicts future work quality.</a:t>
             </a:r>
           </a:p>
         </p:txBody>
@@ -6983,7 +7054,7 @@
               </a:defRPr>
             </a:pPr>
             <a:r>
-              <a:t>The two-role payment journey and long-text mobile layout passed in Edge.</a:t>
+              <a:t>Visual demo mode checks interface flow and mobile layout; it does not exercise the live database.</a:t>
             </a:r>
           </a:p>
         </p:txBody>
@@ -9579,7 +9650,7 @@
               </a:defRPr>
             </a:pPr>
             <a:r>
-              <a:t>A five-minute live demonstration</a:t>
+              <a:t>A five-step connected demonstration</a:t>
             </a:r>
           </a:p>
         </p:txBody>
@@ -9618,7 +9689,7 @@
               </a:defRPr>
             </a:pPr>
             <a:r>
-              <a:t>Use the connected local preview, not the browser-only demo mode.</a:t>
+              <a:t>Use the local API and database preview to show each change as it happens.</a:t>
             </a:r>
           </a:p>
         </p:txBody>
@@ -10774,7 +10845,7 @@
               </a:defRPr>
             </a:pPr>
             <a:r>
-              <a:t>CONCLUSION</a:t>
+              <a:t>PANEL QUESTIONS</a:t>
             </a:r>
           </a:p>
         </p:txBody>
@@ -10813,7 +10884,7 @@
               </a:defRPr>
             </a:pPr>
             <a:r>
-              <a:t>A working prototype with clear next measurements</a:t>
+              <a:t>Three questions the panel may ask</a:t>
             </a:r>
           </a:p>
         </p:txBody>
@@ -10852,7 +10923,7 @@
               </a:defRPr>
             </a:pPr>
             <a:r>
-              <a:t>The database is the product's backbone; our claims stop where the evidence stops.</a:t>
+              <a:t>Answer with the implemented rule, then state the remaining evidence gap.</a:t>
             </a:r>
           </a:p>
         </p:txBody>
@@ -10966,6 +11037,879 @@
             </a:pPr>
             <a:r>
               <a:t>15</a:t>
+            </a:r>
+          </a:p>
+        </p:txBody>
+      </p:sp>
+      <p:sp>
+        <p:nvSpPr>
+          <p:cNvPr id="10" name="Rounded Rectangle 9"/>
+          <p:cNvSpPr/>
+          <p:nvPr/>
+        </p:nvSpPr>
+        <p:spPr>
+          <a:xfrm>
+            <a:off x="658368" y="1865376"/>
+            <a:ext cx="3438144" cy="3246120"/>
+          </a:xfrm>
+          <a:prstGeom prst="roundRect">
+            <a:avLst>
+              <a:gd name="adj" fmla="val 6000"/>
+            </a:avLst>
+          </a:prstGeom>
+          <a:solidFill>
+            <a:srgbClr val="FFFFFF"/>
+          </a:solidFill>
+          <a:ln w="12700">
+            <a:solidFill>
+              <a:srgbClr val="CDD8CD"/>
+            </a:solidFill>
+          </a:ln>
+        </p:spPr>
+        <p:style>
+          <a:lnRef idx="1">
+            <a:schemeClr val="accent1"/>
+          </a:lnRef>
+          <a:fillRef idx="3">
+            <a:schemeClr val="accent1"/>
+          </a:fillRef>
+          <a:effectRef idx="2">
+            <a:schemeClr val="accent1"/>
+          </a:effectRef>
+          <a:fontRef idx="minor">
+            <a:schemeClr val="lt1"/>
+          </a:fontRef>
+        </p:style>
+        <p:txBody>
+          <a:bodyPr rtlCol="0" anchor="ctr"/>
+          <a:lstStyle/>
+          <a:p>
+            <a:pPr algn="ctr"/>
+          </a:p>
+        </p:txBody>
+      </p:sp>
+      <p:sp>
+        <p:nvSpPr>
+          <p:cNvPr id="11" name="Rectangle 10"/>
+          <p:cNvSpPr/>
+          <p:nvPr/>
+        </p:nvSpPr>
+        <p:spPr>
+          <a:xfrm>
+            <a:off x="658368" y="1865376"/>
+            <a:ext cx="64008" cy="3246120"/>
+          </a:xfrm>
+          <a:prstGeom prst="rect">
+            <a:avLst/>
+          </a:prstGeom>
+          <a:solidFill>
+            <a:srgbClr val="426A54"/>
+          </a:solidFill>
+          <a:ln>
+            <a:noFill/>
+          </a:ln>
+        </p:spPr>
+        <p:style>
+          <a:lnRef idx="1">
+            <a:schemeClr val="accent1"/>
+          </a:lnRef>
+          <a:fillRef idx="3">
+            <a:schemeClr val="accent1"/>
+          </a:fillRef>
+          <a:effectRef idx="2">
+            <a:schemeClr val="accent1"/>
+          </a:effectRef>
+          <a:fontRef idx="minor">
+            <a:schemeClr val="lt1"/>
+          </a:fontRef>
+        </p:style>
+        <p:txBody>
+          <a:bodyPr rtlCol="0" anchor="ctr"/>
+          <a:lstStyle/>
+          <a:p>
+            <a:pPr algn="ctr"/>
+          </a:p>
+        </p:txBody>
+      </p:sp>
+      <p:sp>
+        <p:nvSpPr>
+          <p:cNvPr id="12" name="TextBox 11"/>
+          <p:cNvSpPr txBox="1"/>
+          <p:nvPr/>
+        </p:nvSpPr>
+        <p:spPr>
+          <a:xfrm>
+            <a:off x="896112" y="2039112"/>
+            <a:ext cx="2980944" cy="365760"/>
+          </a:xfrm>
+          <a:prstGeom prst="rect">
+            <a:avLst/>
+          </a:prstGeom>
+          <a:noFill/>
+        </p:spPr>
+        <p:txBody>
+          <a:bodyPr wrap="square" lIns="13716" rIns="13716" tIns="13716" bIns="13716" anchor="t">
+            <a:spAutoFit/>
+          </a:bodyPr>
+          <a:lstStyle/>
+          <a:p>
+            <a:pPr>
+              <a:spcAft>
+                <a:spcPts val="0"/>
+              </a:spcAft>
+              <a:defRPr sz="1900" b="1">
+                <a:solidFill>
+                  <a:srgbClr val="20362E"/>
+                </a:solidFill>
+                <a:latin typeface="Aptos"/>
+              </a:defRPr>
+            </a:pPr>
+            <a:r>
+              <a:t>TWO WINNERS?</a:t>
+            </a:r>
+          </a:p>
+        </p:txBody>
+      </p:sp>
+      <p:sp>
+        <p:nvSpPr>
+          <p:cNvPr id="13" name="TextBox 12"/>
+          <p:cNvSpPr txBox="1"/>
+          <p:nvPr/>
+        </p:nvSpPr>
+        <p:spPr>
+          <a:xfrm>
+            <a:off x="896112" y="2505456"/>
+            <a:ext cx="2962656" cy="2514600"/>
+          </a:xfrm>
+          <a:prstGeom prst="rect">
+            <a:avLst/>
+          </a:prstGeom>
+          <a:noFill/>
+        </p:spPr>
+        <p:txBody>
+          <a:bodyPr wrap="square" lIns="13716" rIns="13716" tIns="13716" bIns="13716" anchor="t">
+            <a:spAutoFit/>
+          </a:bodyPr>
+          <a:lstStyle/>
+          <a:p>
+            <a:pPr>
+              <a:spcAft>
+                <a:spcPts val="0"/>
+              </a:spcAft>
+              <a:defRPr sz="1600" b="0">
+                <a:solidFill>
+                  <a:srgbClr val="5B6F63"/>
+                </a:solidFill>
+                <a:latin typeface="Aptos"/>
+              </a:defRPr>
+            </a:pPr>
+            <a:r>
+              <a:t>A transaction, row lock, trigger and unique contract rule allow one winner per job. Native server concurrency still needs a run.</a:t>
+            </a:r>
+          </a:p>
+        </p:txBody>
+      </p:sp>
+      <p:sp>
+        <p:nvSpPr>
+          <p:cNvPr id="14" name="Rounded Rectangle 13"/>
+          <p:cNvSpPr/>
+          <p:nvPr/>
+        </p:nvSpPr>
+        <p:spPr>
+          <a:xfrm>
+            <a:off x="4370832" y="1865376"/>
+            <a:ext cx="3438144" cy="3246120"/>
+          </a:xfrm>
+          <a:prstGeom prst="roundRect">
+            <a:avLst>
+              <a:gd name="adj" fmla="val 6000"/>
+            </a:avLst>
+          </a:prstGeom>
+          <a:solidFill>
+            <a:srgbClr val="EEE7DE"/>
+          </a:solidFill>
+          <a:ln w="12700">
+            <a:solidFill>
+              <a:srgbClr val="CDD8CD"/>
+            </a:solidFill>
+          </a:ln>
+        </p:spPr>
+        <p:style>
+          <a:lnRef idx="1">
+            <a:schemeClr val="accent1"/>
+          </a:lnRef>
+          <a:fillRef idx="3">
+            <a:schemeClr val="accent1"/>
+          </a:fillRef>
+          <a:effectRef idx="2">
+            <a:schemeClr val="accent1"/>
+          </a:effectRef>
+          <a:fontRef idx="minor">
+            <a:schemeClr val="lt1"/>
+          </a:fontRef>
+        </p:style>
+        <p:txBody>
+          <a:bodyPr rtlCol="0" anchor="ctr"/>
+          <a:lstStyle/>
+          <a:p>
+            <a:pPr algn="ctr"/>
+          </a:p>
+        </p:txBody>
+      </p:sp>
+      <p:sp>
+        <p:nvSpPr>
+          <p:cNvPr id="15" name="Rectangle 14"/>
+          <p:cNvSpPr/>
+          <p:nvPr/>
+        </p:nvSpPr>
+        <p:spPr>
+          <a:xfrm>
+            <a:off x="4370832" y="1865376"/>
+            <a:ext cx="64008" cy="3246120"/>
+          </a:xfrm>
+          <a:prstGeom prst="rect">
+            <a:avLst/>
+          </a:prstGeom>
+          <a:solidFill>
+            <a:srgbClr val="A86948"/>
+          </a:solidFill>
+          <a:ln>
+            <a:noFill/>
+          </a:ln>
+        </p:spPr>
+        <p:style>
+          <a:lnRef idx="1">
+            <a:schemeClr val="accent1"/>
+          </a:lnRef>
+          <a:fillRef idx="3">
+            <a:schemeClr val="accent1"/>
+          </a:fillRef>
+          <a:effectRef idx="2">
+            <a:schemeClr val="accent1"/>
+          </a:effectRef>
+          <a:fontRef idx="minor">
+            <a:schemeClr val="lt1"/>
+          </a:fontRef>
+        </p:style>
+        <p:txBody>
+          <a:bodyPr rtlCol="0" anchor="ctr"/>
+          <a:lstStyle/>
+          <a:p>
+            <a:pPr algn="ctr"/>
+          </a:p>
+        </p:txBody>
+      </p:sp>
+      <p:sp>
+        <p:nvSpPr>
+          <p:cNvPr id="16" name="TextBox 15"/>
+          <p:cNvSpPr txBox="1"/>
+          <p:nvPr/>
+        </p:nvSpPr>
+        <p:spPr>
+          <a:xfrm>
+            <a:off x="4608576" y="2039112"/>
+            <a:ext cx="2980944" cy="365760"/>
+          </a:xfrm>
+          <a:prstGeom prst="rect">
+            <a:avLst/>
+          </a:prstGeom>
+          <a:noFill/>
+        </p:spPr>
+        <p:txBody>
+          <a:bodyPr wrap="square" lIns="13716" rIns="13716" tIns="13716" bIns="13716" anchor="t">
+            <a:spAutoFit/>
+          </a:bodyPr>
+          <a:lstStyle/>
+          <a:p>
+            <a:pPr>
+              <a:spcAft>
+                <a:spcPts val="0"/>
+              </a:spcAft>
+              <a:defRPr sz="1900" b="1">
+                <a:solidFill>
+                  <a:srgbClr val="20362E"/>
+                </a:solidFill>
+                <a:latin typeface="Aptos"/>
+              </a:defRPr>
+            </a:pPr>
+            <a:r>
+              <a:t>PAYMENT VERIFIED?</a:t>
+            </a:r>
+          </a:p>
+        </p:txBody>
+      </p:sp>
+      <p:sp>
+        <p:nvSpPr>
+          <p:cNvPr id="17" name="TextBox 16"/>
+          <p:cNvSpPr txBox="1"/>
+          <p:nvPr/>
+        </p:nvSpPr>
+        <p:spPr>
+          <a:xfrm>
+            <a:off x="4608576" y="2505456"/>
+            <a:ext cx="2962656" cy="2514600"/>
+          </a:xfrm>
+          <a:prstGeom prst="rect">
+            <a:avLst/>
+          </a:prstGeom>
+          <a:noFill/>
+        </p:spPr>
+        <p:txBody>
+          <a:bodyPr wrap="square" lIns="13716" rIns="13716" tIns="13716" bIns="13716" anchor="t">
+            <a:spAutoFit/>
+          </a:bodyPr>
+          <a:lstStyle/>
+          <a:p>
+            <a:pPr>
+              <a:spcAft>
+                <a:spcPts val="0"/>
+              </a:spcAft>
+              <a:defRPr sz="1600" b="0">
+                <a:solidFill>
+                  <a:srgbClr val="5B6F63"/>
+                </a:solidFill>
+                <a:latin typeface="Aptos"/>
+              </a:defRPr>
+            </a:pPr>
+            <a:r>
+              <a:t>No. Paid records two user acknowledgments. There is no bank integration, escrow or independent confirmation.</a:t>
+            </a:r>
+          </a:p>
+        </p:txBody>
+      </p:sp>
+      <p:sp>
+        <p:nvSpPr>
+          <p:cNvPr id="18" name="Rounded Rectangle 17"/>
+          <p:cNvSpPr/>
+          <p:nvPr/>
+        </p:nvSpPr>
+        <p:spPr>
+          <a:xfrm>
+            <a:off x="8083296" y="1865376"/>
+            <a:ext cx="3438144" cy="3246120"/>
+          </a:xfrm>
+          <a:prstGeom prst="roundRect">
+            <a:avLst>
+              <a:gd name="adj" fmla="val 6000"/>
+            </a:avLst>
+          </a:prstGeom>
+          <a:solidFill>
+            <a:srgbClr val="E4ECE4"/>
+          </a:solidFill>
+          <a:ln w="12700">
+            <a:solidFill>
+              <a:srgbClr val="CDD8CD"/>
+            </a:solidFill>
+          </a:ln>
+        </p:spPr>
+        <p:style>
+          <a:lnRef idx="1">
+            <a:schemeClr val="accent1"/>
+          </a:lnRef>
+          <a:fillRef idx="3">
+            <a:schemeClr val="accent1"/>
+          </a:fillRef>
+          <a:effectRef idx="2">
+            <a:schemeClr val="accent1"/>
+          </a:effectRef>
+          <a:fontRef idx="minor">
+            <a:schemeClr val="lt1"/>
+          </a:fontRef>
+        </p:style>
+        <p:txBody>
+          <a:bodyPr rtlCol="0" anchor="ctr"/>
+          <a:lstStyle/>
+          <a:p>
+            <a:pPr algn="ctr"/>
+          </a:p>
+        </p:txBody>
+      </p:sp>
+      <p:sp>
+        <p:nvSpPr>
+          <p:cNvPr id="19" name="Rectangle 18"/>
+          <p:cNvSpPr/>
+          <p:nvPr/>
+        </p:nvSpPr>
+        <p:spPr>
+          <a:xfrm>
+            <a:off x="8083296" y="1865376"/>
+            <a:ext cx="64008" cy="3246120"/>
+          </a:xfrm>
+          <a:prstGeom prst="rect">
+            <a:avLst/>
+          </a:prstGeom>
+          <a:solidFill>
+            <a:srgbClr val="426A54"/>
+          </a:solidFill>
+          <a:ln>
+            <a:noFill/>
+          </a:ln>
+        </p:spPr>
+        <p:style>
+          <a:lnRef idx="1">
+            <a:schemeClr val="accent1"/>
+          </a:lnRef>
+          <a:fillRef idx="3">
+            <a:schemeClr val="accent1"/>
+          </a:fillRef>
+          <a:effectRef idx="2">
+            <a:schemeClr val="accent1"/>
+          </a:effectRef>
+          <a:fontRef idx="minor">
+            <a:schemeClr val="lt1"/>
+          </a:fontRef>
+        </p:style>
+        <p:txBody>
+          <a:bodyPr rtlCol="0" anchor="ctr"/>
+          <a:lstStyle/>
+          <a:p>
+            <a:pPr algn="ctr"/>
+          </a:p>
+        </p:txBody>
+      </p:sp>
+      <p:sp>
+        <p:nvSpPr>
+          <p:cNvPr id="20" name="TextBox 19"/>
+          <p:cNvSpPr txBox="1"/>
+          <p:nvPr/>
+        </p:nvSpPr>
+        <p:spPr>
+          <a:xfrm>
+            <a:off x="8321040" y="2039112"/>
+            <a:ext cx="2980944" cy="365760"/>
+          </a:xfrm>
+          <a:prstGeom prst="rect">
+            <a:avLst/>
+          </a:prstGeom>
+          <a:noFill/>
+        </p:spPr>
+        <p:txBody>
+          <a:bodyPr wrap="square" lIns="13716" rIns="13716" tIns="13716" bIns="13716" anchor="t">
+            <a:spAutoFit/>
+          </a:bodyPr>
+          <a:lstStyle/>
+          <a:p>
+            <a:pPr>
+              <a:spcAft>
+                <a:spcPts val="0"/>
+              </a:spcAft>
+              <a:defRPr sz="1900" b="1">
+                <a:solidFill>
+                  <a:srgbClr val="20362E"/>
+                </a:solidFill>
+                <a:latin typeface="Aptos"/>
+              </a:defRPr>
+            </a:pPr>
+            <a:r>
+              <a:t>FASTER OR FAIRER?</a:t>
+            </a:r>
+          </a:p>
+        </p:txBody>
+      </p:sp>
+      <p:sp>
+        <p:nvSpPr>
+          <p:cNvPr id="21" name="TextBox 20"/>
+          <p:cNvSpPr txBox="1"/>
+          <p:nvPr/>
+        </p:nvSpPr>
+        <p:spPr>
+          <a:xfrm>
+            <a:off x="8321040" y="2505456"/>
+            <a:ext cx="2962656" cy="2514600"/>
+          </a:xfrm>
+          <a:prstGeom prst="rect">
+            <a:avLst/>
+          </a:prstGeom>
+          <a:noFill/>
+        </p:spPr>
+        <p:txBody>
+          <a:bodyPr wrap="square" lIns="13716" rIns="13716" tIns="13716" bIns="13716" anchor="t">
+            <a:spAutoFit/>
+          </a:bodyPr>
+          <a:lstStyle/>
+          <a:p>
+            <a:pPr>
+              <a:spcAft>
+                <a:spcPts val="0"/>
+              </a:spcAft>
+              <a:defRPr sz="1600" b="0">
+                <a:solidFill>
+                  <a:srgbClr val="5B6F63"/>
+                </a:solidFill>
+                <a:latin typeface="Aptos"/>
+              </a:defRPr>
+            </a:pPr>
+            <a:r>
+              <a:t>Not yet measured. Define a baseline, repeat query tests on PostgreSQL, and assess fit against labeled examples.</a:t>
+            </a:r>
+          </a:p>
+        </p:txBody>
+      </p:sp>
+      <p:sp>
+        <p:nvSpPr>
+          <p:cNvPr id="22" name="TextBox 21"/>
+          <p:cNvSpPr txBox="1"/>
+          <p:nvPr/>
+        </p:nvSpPr>
+        <p:spPr>
+          <a:xfrm>
+            <a:off x="969264" y="5532120"/>
+            <a:ext cx="10241280" cy="402336"/>
+          </a:xfrm>
+          <a:prstGeom prst="rect">
+            <a:avLst/>
+          </a:prstGeom>
+          <a:noFill/>
+        </p:spPr>
+        <p:txBody>
+          <a:bodyPr wrap="square" lIns="13716" rIns="13716" tIns="13716" bIns="13716" anchor="t">
+            <a:spAutoFit/>
+          </a:bodyPr>
+          <a:lstStyle/>
+          <a:p>
+            <a:pPr algn="ctr">
+              <a:spcAft>
+                <a:spcPts val="0"/>
+              </a:spcAft>
+              <a:defRPr sz="1700" b="0">
+                <a:solidFill>
+                  <a:srgbClr val="5B6F63"/>
+                </a:solidFill>
+                <a:latin typeface="Aptos"/>
+              </a:defRPr>
+            </a:pPr>
+            <a:r>
+              <a:t>A precise answer is stronger than a performance or impact number we cannot support.</a:t>
+            </a:r>
+          </a:p>
+        </p:txBody>
+      </p:sp>
+    </p:spTree>
+  </p:cSld>
+  <p:clrMapOvr>
+    <a:masterClrMapping/>
+  </p:clrMapOvr>
+</p:sld>
+</file>
+
+<file path=ppt/slides/slide16.xml><?xml version="1.0" encoding="utf-8"?>
+<p:sld xmlns:a="http://schemas.openxmlformats.org/drawingml/2006/main" xmlns:p="http://schemas.openxmlformats.org/presentationml/2006/main" xmlns:r="http://schemas.openxmlformats.org/officeDocument/2006/relationships">
+  <p:cSld>
+    <p:spTree>
+      <p:nvGrpSpPr>
+        <p:cNvPr id="1" name=""/>
+        <p:cNvGrpSpPr/>
+        <p:nvPr/>
+      </p:nvGrpSpPr>
+      <p:grpSpPr/>
+      <p:sp>
+        <p:nvSpPr>
+          <p:cNvPr id="2" name="Rectangle 1"/>
+          <p:cNvSpPr/>
+          <p:nvPr/>
+        </p:nvSpPr>
+        <p:spPr>
+          <a:xfrm>
+            <a:off x="0" y="0"/>
+            <a:ext cx="12191695" cy="6858000"/>
+          </a:xfrm>
+          <a:prstGeom prst="rect">
+            <a:avLst/>
+          </a:prstGeom>
+          <a:solidFill>
+            <a:srgbClr val="F8F7F2"/>
+          </a:solidFill>
+          <a:ln>
+            <a:noFill/>
+          </a:ln>
+        </p:spPr>
+        <p:style>
+          <a:lnRef idx="1">
+            <a:schemeClr val="accent1"/>
+          </a:lnRef>
+          <a:fillRef idx="3">
+            <a:schemeClr val="accent1"/>
+          </a:fillRef>
+          <a:effectRef idx="2">
+            <a:schemeClr val="accent1"/>
+          </a:effectRef>
+          <a:fontRef idx="minor">
+            <a:schemeClr val="lt1"/>
+          </a:fontRef>
+        </p:style>
+        <p:txBody>
+          <a:bodyPr rtlCol="0" anchor="ctr"/>
+          <a:lstStyle/>
+          <a:p>
+            <a:pPr algn="ctr"/>
+          </a:p>
+        </p:txBody>
+      </p:sp>
+      <p:sp>
+        <p:nvSpPr>
+          <p:cNvPr id="3" name="TextBox 2"/>
+          <p:cNvSpPr txBox="1"/>
+          <p:nvPr/>
+        </p:nvSpPr>
+        <p:spPr>
+          <a:xfrm>
+            <a:off x="502920" y="256032"/>
+            <a:ext cx="4937760" cy="237744"/>
+          </a:xfrm>
+          <a:prstGeom prst="rect">
+            <a:avLst/>
+          </a:prstGeom>
+          <a:noFill/>
+        </p:spPr>
+        <p:txBody>
+          <a:bodyPr wrap="square" lIns="13716" rIns="13716" tIns="13716" bIns="13716" anchor="t">
+            <a:spAutoFit/>
+          </a:bodyPr>
+          <a:lstStyle/>
+          <a:p>
+            <a:pPr>
+              <a:spcAft>
+                <a:spcPts val="0"/>
+              </a:spcAft>
+              <a:defRPr sz="1000" b="1">
+                <a:solidFill>
+                  <a:srgbClr val="426A54"/>
+                </a:solidFill>
+                <a:latin typeface="Aptos"/>
+              </a:defRPr>
+            </a:pPr>
+            <a:r>
+              <a:t>SKILLCRAFT  /  DBTHON 2026</a:t>
+            </a:r>
+          </a:p>
+        </p:txBody>
+      </p:sp>
+      <p:sp>
+        <p:nvSpPr>
+          <p:cNvPr id="4" name="TextBox 3"/>
+          <p:cNvSpPr txBox="1"/>
+          <p:nvPr/>
+        </p:nvSpPr>
+        <p:spPr>
+          <a:xfrm>
+            <a:off x="9144000" y="256032"/>
+            <a:ext cx="2496312" cy="237744"/>
+          </a:xfrm>
+          <a:prstGeom prst="rect">
+            <a:avLst/>
+          </a:prstGeom>
+          <a:noFill/>
+        </p:spPr>
+        <p:txBody>
+          <a:bodyPr wrap="square" lIns="13716" rIns="13716" tIns="13716" bIns="13716" anchor="t">
+            <a:spAutoFit/>
+          </a:bodyPr>
+          <a:lstStyle/>
+          <a:p>
+            <a:pPr algn="r">
+              <a:spcAft>
+                <a:spcPts val="0"/>
+              </a:spcAft>
+              <a:defRPr sz="1000" b="1">
+                <a:solidFill>
+                  <a:srgbClr val="5B6F63"/>
+                </a:solidFill>
+                <a:latin typeface="Aptos"/>
+              </a:defRPr>
+            </a:pPr>
+            <a:r>
+              <a:t>CONCLUSION</a:t>
+            </a:r>
+          </a:p>
+        </p:txBody>
+      </p:sp>
+      <p:sp>
+        <p:nvSpPr>
+          <p:cNvPr id="5" name="TextBox 4"/>
+          <p:cNvSpPr txBox="1"/>
+          <p:nvPr/>
+        </p:nvSpPr>
+        <p:spPr>
+          <a:xfrm>
+            <a:off x="502920" y="640080"/>
+            <a:ext cx="11064240" cy="530352"/>
+          </a:xfrm>
+          <a:prstGeom prst="rect">
+            <a:avLst/>
+          </a:prstGeom>
+          <a:noFill/>
+        </p:spPr>
+        <p:txBody>
+          <a:bodyPr wrap="square" lIns="13716" rIns="13716" tIns="13716" bIns="13716" anchor="t">
+            <a:spAutoFit/>
+          </a:bodyPr>
+          <a:lstStyle/>
+          <a:p>
+            <a:pPr>
+              <a:spcAft>
+                <a:spcPts val="0"/>
+              </a:spcAft>
+              <a:defRPr sz="3000" b="1">
+                <a:solidFill>
+                  <a:srgbClr val="20362E"/>
+                </a:solidFill>
+                <a:latin typeface="Aptos"/>
+              </a:defRPr>
+            </a:pPr>
+            <a:r>
+              <a:t>A working prototype with clear next measurements</a:t>
+            </a:r>
+          </a:p>
+        </p:txBody>
+      </p:sp>
+      <p:sp>
+        <p:nvSpPr>
+          <p:cNvPr id="6" name="TextBox 5"/>
+          <p:cNvSpPr txBox="1"/>
+          <p:nvPr/>
+        </p:nvSpPr>
+        <p:spPr>
+          <a:xfrm>
+            <a:off x="521207" y="1234440"/>
+            <a:ext cx="10972800" cy="411480"/>
+          </a:xfrm>
+          <a:prstGeom prst="rect">
+            <a:avLst/>
+          </a:prstGeom>
+          <a:noFill/>
+        </p:spPr>
+        <p:txBody>
+          <a:bodyPr wrap="square" lIns="13716" rIns="13716" tIns="13716" bIns="13716" anchor="t">
+            <a:spAutoFit/>
+          </a:bodyPr>
+          <a:lstStyle/>
+          <a:p>
+            <a:pPr>
+              <a:spcAft>
+                <a:spcPts val="0"/>
+              </a:spcAft>
+              <a:defRPr sz="1500" b="0">
+                <a:solidFill>
+                  <a:srgbClr val="5B6F63"/>
+                </a:solidFill>
+                <a:latin typeface="Aptos"/>
+              </a:defRPr>
+            </a:pPr>
+            <a:r>
+              <a:t>The database is the product's backbone; our claims stop where the evidence stops.</a:t>
+            </a:r>
+          </a:p>
+        </p:txBody>
+      </p:sp>
+      <p:cxnSp>
+        <p:nvCxnSpPr>
+          <p:cNvPr id="7" name="Connector 6"/>
+          <p:cNvCxnSpPr/>
+          <p:nvPr/>
+        </p:nvCxnSpPr>
+        <p:spPr>
+          <a:xfrm>
+            <a:off x="502920" y="6501384"/>
+            <a:ext cx="11183112" cy="0"/>
+          </a:xfrm>
+          <a:prstGeom prst="line">
+            <a:avLst/>
+          </a:prstGeom>
+          <a:ln w="12700">
+            <a:solidFill>
+              <a:srgbClr val="CDD8CD"/>
+            </a:solidFill>
+          </a:ln>
+        </p:spPr>
+        <p:style>
+          <a:lnRef idx="2">
+            <a:schemeClr val="accent1"/>
+          </a:lnRef>
+          <a:fillRef idx="0">
+            <a:schemeClr val="accent1"/>
+          </a:fillRef>
+          <a:effectRef idx="1">
+            <a:schemeClr val="accent1"/>
+          </a:effectRef>
+          <a:fontRef idx="minor">
+            <a:schemeClr val="tx1"/>
+          </a:fontRef>
+        </p:style>
+      </p:cxnSp>
+      <p:sp>
+        <p:nvSpPr>
+          <p:cNvPr id="8" name="TextBox 7"/>
+          <p:cNvSpPr txBox="1"/>
+          <p:nvPr/>
+        </p:nvSpPr>
+        <p:spPr>
+          <a:xfrm>
+            <a:off x="512064" y="6556248"/>
+            <a:ext cx="6400800" cy="182880"/>
+          </a:xfrm>
+          <a:prstGeom prst="rect">
+            <a:avLst/>
+          </a:prstGeom>
+          <a:noFill/>
+        </p:spPr>
+        <p:txBody>
+          <a:bodyPr wrap="square" lIns="13716" rIns="13716" tIns="13716" bIns="13716" anchor="t">
+            <a:spAutoFit/>
+          </a:bodyPr>
+          <a:lstStyle/>
+          <a:p>
+            <a:pPr>
+              <a:spcAft>
+                <a:spcPts val="0"/>
+              </a:spcAft>
+              <a:defRPr sz="900" b="0">
+                <a:solidFill>
+                  <a:srgbClr val="5B6F63"/>
+                </a:solidFill>
+                <a:latin typeface="Aptos"/>
+              </a:defRPr>
+            </a:pPr>
+            <a:r>
+              <a:t>SkillCraft  •  database systems prototype</a:t>
+            </a:r>
+          </a:p>
+        </p:txBody>
+      </p:sp>
+      <p:sp>
+        <p:nvSpPr>
+          <p:cNvPr id="9" name="TextBox 8"/>
+          <p:cNvSpPr txBox="1"/>
+          <p:nvPr/>
+        </p:nvSpPr>
+        <p:spPr>
+          <a:xfrm>
+            <a:off x="11082528" y="6547104"/>
+            <a:ext cx="548640" cy="182880"/>
+          </a:xfrm>
+          <a:prstGeom prst="rect">
+            <a:avLst/>
+          </a:prstGeom>
+          <a:noFill/>
+        </p:spPr>
+        <p:txBody>
+          <a:bodyPr wrap="square" lIns="13716" rIns="13716" tIns="13716" bIns="13716" anchor="t">
+            <a:spAutoFit/>
+          </a:bodyPr>
+          <a:lstStyle/>
+          <a:p>
+            <a:pPr algn="r">
+              <a:spcAft>
+                <a:spcPts val="0"/>
+              </a:spcAft>
+              <a:defRPr sz="900" b="0">
+                <a:solidFill>
+                  <a:srgbClr val="5B6F63"/>
+                </a:solidFill>
+                <a:latin typeface="Aptos"/>
+              </a:defRPr>
+            </a:pPr>
+            <a:r>
+              <a:t>16</a:t>
             </a:r>
           </a:p>
         </p:txBody>

</xml_diff>